<commit_message>
Add operating concrete vibrator observation
Co-authored-by: arena-agent <297053741+arena-agent@users.noreply.github.com>
</commit_message>
<xml_diff>
--- a/EHS_Night_Concrete_Pouring_Audit_Findings.pptx
+++ b/EHS_Night_Concrete_Pouring_Audit_Findings.pptx
@@ -15,6 +15,7 @@
     <p:sldId id="263" r:id="rId14"/>
     <p:sldId id="264" r:id="rId15"/>
     <p:sldId id="265" r:id="rId16"/>
+    <p:sldId id="266" r:id="rId17"/>
   </p:sldIdLst>
   <p:sldSz cx="12191695" cy="6858000" type="screen4x3"/>
   <p:notesSz cx="6858000" cy="9144000"/>
@@ -4695,7 +4696,7 @@
                 <a:latin typeface="Aptos"/>
                 <a:spc val="80"/>
               </a:rPr>
-              <a:t>01 / 10</a:t>
+              <a:t>01 / 11</a:t>
             </a:r>
           </a:p>
         </p:txBody>
@@ -4909,6 +4910,1600 @@
                 <a:latin typeface="Aptos"/>
                 <a:spc val="80"/>
               </a:rPr>
+              <a:t>OBSERVATION 08  /  CORRECTIVE ACTION</a:t>
+            </a:r>
+          </a:p>
+        </p:txBody>
+      </p:sp>
+      <p:sp>
+        <p:nvSpPr>
+          <p:cNvPr id="7" name="TextBox 6"/>
+          <p:cNvSpPr txBox="1"/>
+          <p:nvPr/>
+        </p:nvSpPr>
+        <p:spPr>
+          <a:xfrm>
+            <a:off x="9628632" y="6510528"/>
+            <a:ext cx="2148840" cy="146304"/>
+          </a:xfrm>
+          <a:prstGeom prst="rect">
+            <a:avLst/>
+          </a:prstGeom>
+          <a:noFill/>
+        </p:spPr>
+        <p:txBody>
+          <a:bodyPr wrap="square" lIns="0" rIns="0" tIns="0" bIns="0" anchor="t">
+            <a:spAutoFit/>
+          </a:bodyPr>
+          <a:lstStyle/>
+          <a:p>
+            <a:pPr algn="r">
+              <a:spcBef>
+                <a:spcPts val="0"/>
+              </a:spcBef>
+              <a:spcAft>
+                <a:spcPts val="0"/>
+              </a:spcAft>
+            </a:pPr>
+            <a:r>
+              <a:rPr sz="680" b="1" i="0">
+                <a:solidFill>
+                  <a:srgbClr val="6E8B91"/>
+                </a:solidFill>
+                <a:latin typeface="Aptos"/>
+                <a:spc val="60"/>
+              </a:rPr>
+              <a:t>SIEMENS ENERGY  /  10</a:t>
+            </a:r>
+          </a:p>
+        </p:txBody>
+      </p:sp>
+      <p:sp>
+        <p:nvSpPr>
+          <p:cNvPr id="8" name="TextBox 7"/>
+          <p:cNvSpPr txBox="1"/>
+          <p:nvPr/>
+        </p:nvSpPr>
+        <p:spPr>
+          <a:xfrm>
+            <a:off x="457200" y="832104"/>
+            <a:ext cx="393192" cy="274320"/>
+          </a:xfrm>
+          <a:prstGeom prst="rect">
+            <a:avLst/>
+          </a:prstGeom>
+          <a:noFill/>
+        </p:spPr>
+        <p:txBody>
+          <a:bodyPr wrap="square" lIns="0" rIns="0" tIns="0" bIns="0" anchor="t">
+            <a:spAutoFit/>
+          </a:bodyPr>
+          <a:lstStyle/>
+          <a:p>
+            <a:pPr algn="l">
+              <a:spcBef>
+                <a:spcPts val="0"/>
+              </a:spcBef>
+              <a:spcAft>
+                <a:spcPts val="0"/>
+              </a:spcAft>
+            </a:pPr>
+            <a:r>
+              <a:rPr sz="1400" b="1" i="0">
+                <a:solidFill>
+                  <a:srgbClr val="00B5E2"/>
+                </a:solidFill>
+                <a:latin typeface="Aptos Display"/>
+              </a:rPr>
+              <a:t>08</a:t>
+            </a:r>
+          </a:p>
+        </p:txBody>
+      </p:sp>
+      <p:sp>
+        <p:nvSpPr>
+          <p:cNvPr id="9" name="TextBox 8"/>
+          <p:cNvSpPr txBox="1"/>
+          <p:nvPr/>
+        </p:nvSpPr>
+        <p:spPr>
+          <a:xfrm>
+            <a:off x="960120" y="886968"/>
+            <a:ext cx="2743200" cy="164592"/>
+          </a:xfrm>
+          <a:prstGeom prst="rect">
+            <a:avLst/>
+          </a:prstGeom>
+          <a:noFill/>
+        </p:spPr>
+        <p:txBody>
+          <a:bodyPr wrap="square" lIns="0" rIns="0" tIns="0" bIns="0" anchor="t">
+            <a:spAutoFit/>
+          </a:bodyPr>
+          <a:lstStyle/>
+          <a:p>
+            <a:pPr algn="l">
+              <a:spcBef>
+                <a:spcPts val="0"/>
+              </a:spcBef>
+              <a:spcAft>
+                <a:spcPts val="0"/>
+              </a:spcAft>
+            </a:pPr>
+            <a:r>
+              <a:rPr sz="750" b="1" i="0">
+                <a:solidFill>
+                  <a:srgbClr val="A9BEC3"/>
+                </a:solidFill>
+                <a:latin typeface="Aptos"/>
+                <a:spc val="90"/>
+              </a:rPr>
+              <a:t>FIELD OBSERVATION</a:t>
+            </a:r>
+          </a:p>
+        </p:txBody>
+      </p:sp>
+      <p:sp>
+        <p:nvSpPr>
+          <p:cNvPr id="10" name="Rounded Rectangle 9"/>
+          <p:cNvSpPr/>
+          <p:nvPr/>
+        </p:nvSpPr>
+        <p:spPr>
+          <a:xfrm>
+            <a:off x="9829800" y="859536"/>
+            <a:ext cx="1078992" cy="246888"/>
+          </a:xfrm>
+          <a:prstGeom prst="roundRect">
+            <a:avLst/>
+          </a:prstGeom>
+          <a:solidFill>
+            <a:srgbClr val="F04A4A"/>
+          </a:solidFill>
+          <a:ln>
+            <a:noFill/>
+          </a:ln>
+        </p:spPr>
+        <p:style>
+          <a:lnRef idx="1">
+            <a:schemeClr val="accent1"/>
+          </a:lnRef>
+          <a:fillRef idx="3">
+            <a:schemeClr val="accent1"/>
+          </a:fillRef>
+          <a:effectRef idx="2">
+            <a:schemeClr val="accent1"/>
+          </a:effectRef>
+          <a:fontRef idx="minor">
+            <a:schemeClr val="lt1"/>
+          </a:fontRef>
+        </p:style>
+        <p:txBody>
+          <a:bodyPr rtlCol="0" anchor="ctr"/>
+          <a:lstStyle/>
+          <a:p>
+            <a:pPr algn="ctr"/>
+          </a:p>
+        </p:txBody>
+      </p:sp>
+      <p:sp>
+        <p:nvSpPr>
+          <p:cNvPr id="11" name="TextBox 10"/>
+          <p:cNvSpPr txBox="1"/>
+          <p:nvPr/>
+        </p:nvSpPr>
+        <p:spPr>
+          <a:xfrm>
+            <a:off x="9875520" y="918971"/>
+            <a:ext cx="987551" cy="173736"/>
+          </a:xfrm>
+          <a:prstGeom prst="rect">
+            <a:avLst/>
+          </a:prstGeom>
+          <a:noFill/>
+        </p:spPr>
+        <p:txBody>
+          <a:bodyPr wrap="square" lIns="0" rIns="0" tIns="0" bIns="0" anchor="t">
+            <a:spAutoFit/>
+          </a:bodyPr>
+          <a:lstStyle/>
+          <a:p>
+            <a:pPr algn="ctr">
+              <a:spcBef>
+                <a:spcPts val="0"/>
+              </a:spcBef>
+              <a:spcAft>
+                <a:spcPts val="0"/>
+              </a:spcAft>
+            </a:pPr>
+            <a:r>
+              <a:rPr sz="700" b="1" i="0">
+                <a:solidFill>
+                  <a:srgbClr val="F5FAFB"/>
+                </a:solidFill>
+                <a:latin typeface="Aptos"/>
+                <a:spc val="70"/>
+              </a:rPr>
+              <a:t>HIGH</a:t>
+            </a:r>
+          </a:p>
+        </p:txBody>
+      </p:sp>
+      <p:sp>
+        <p:nvSpPr>
+          <p:cNvPr id="12" name="TextBox 11"/>
+          <p:cNvSpPr txBox="1"/>
+          <p:nvPr/>
+        </p:nvSpPr>
+        <p:spPr>
+          <a:xfrm>
+            <a:off x="457200" y="1307592"/>
+            <a:ext cx="6537960" cy="493776"/>
+          </a:xfrm>
+          <a:prstGeom prst="rect">
+            <a:avLst/>
+          </a:prstGeom>
+          <a:noFill/>
+        </p:spPr>
+        <p:txBody>
+          <a:bodyPr wrap="square" lIns="0" rIns="0" tIns="0" bIns="0" anchor="t">
+            <a:spAutoFit/>
+          </a:bodyPr>
+          <a:lstStyle/>
+          <a:p>
+            <a:pPr algn="l">
+              <a:spcBef>
+                <a:spcPts val="0"/>
+              </a:spcBef>
+              <a:spcAft>
+                <a:spcPts val="0"/>
+              </a:spcAft>
+            </a:pPr>
+            <a:r>
+              <a:rPr sz="2400" b="1" i="0">
+                <a:solidFill>
+                  <a:srgbClr val="F5FAFB"/>
+                </a:solidFill>
+                <a:latin typeface="Aptos Display"/>
+              </a:rPr>
+              <a:t>Manual Movement of an Operating Concrete Vibrator</a:t>
+            </a:r>
+          </a:p>
+        </p:txBody>
+      </p:sp>
+      <p:sp>
+        <p:nvSpPr>
+          <p:cNvPr id="13" name="TextBox 12"/>
+          <p:cNvSpPr txBox="1"/>
+          <p:nvPr/>
+        </p:nvSpPr>
+        <p:spPr>
+          <a:xfrm>
+            <a:off x="475488" y="1901952"/>
+            <a:ext cx="6217920" cy="155448"/>
+          </a:xfrm>
+          <a:prstGeom prst="rect">
+            <a:avLst/>
+          </a:prstGeom>
+          <a:noFill/>
+        </p:spPr>
+        <p:txBody>
+          <a:bodyPr wrap="square" lIns="0" rIns="0" tIns="0" bIns="0" anchor="t">
+            <a:spAutoFit/>
+          </a:bodyPr>
+          <a:lstStyle/>
+          <a:p>
+            <a:pPr algn="l">
+              <a:spcBef>
+                <a:spcPts val="0"/>
+              </a:spcBef>
+              <a:spcAft>
+                <a:spcPts val="0"/>
+              </a:spcAft>
+            </a:pPr>
+            <a:r>
+              <a:rPr sz="710" b="1" i="0">
+                <a:solidFill>
+                  <a:srgbClr val="00B5E2"/>
+                </a:solidFill>
+                <a:latin typeface="Aptos"/>
+                <a:spc val="55"/>
+              </a:rPr>
+              <a:t>CONTROL GAP  •  NIGHT CONCRETE POURING OPERATION</a:t>
+            </a:r>
+          </a:p>
+        </p:txBody>
+      </p:sp>
+      <p:sp>
+        <p:nvSpPr>
+          <p:cNvPr id="14" name="Rounded Rectangle 13"/>
+          <p:cNvSpPr/>
+          <p:nvPr/>
+        </p:nvSpPr>
+        <p:spPr>
+          <a:xfrm>
+            <a:off x="457200" y="2240280"/>
+            <a:ext cx="6080760" cy="1161288"/>
+          </a:xfrm>
+          <a:prstGeom prst="roundRect">
+            <a:avLst/>
+          </a:prstGeom>
+          <a:solidFill>
+            <a:srgbClr val="162A30"/>
+          </a:solidFill>
+          <a:ln>
+            <a:noFill/>
+          </a:ln>
+        </p:spPr>
+        <p:style>
+          <a:lnRef idx="1">
+            <a:schemeClr val="accent1"/>
+          </a:lnRef>
+          <a:fillRef idx="3">
+            <a:schemeClr val="accent1"/>
+          </a:fillRef>
+          <a:effectRef idx="2">
+            <a:schemeClr val="accent1"/>
+          </a:effectRef>
+          <a:fontRef idx="minor">
+            <a:schemeClr val="lt1"/>
+          </a:fontRef>
+        </p:style>
+        <p:txBody>
+          <a:bodyPr rtlCol="0" anchor="ctr"/>
+          <a:lstStyle/>
+          <a:p>
+            <a:pPr algn="ctr"/>
+          </a:p>
+        </p:txBody>
+      </p:sp>
+      <p:sp>
+        <p:nvSpPr>
+          <p:cNvPr id="15" name="TextBox 14"/>
+          <p:cNvSpPr txBox="1"/>
+          <p:nvPr/>
+        </p:nvSpPr>
+        <p:spPr>
+          <a:xfrm>
+            <a:off x="667512" y="2450592"/>
+            <a:ext cx="914400" cy="146304"/>
+          </a:xfrm>
+          <a:prstGeom prst="rect">
+            <a:avLst/>
+          </a:prstGeom>
+          <a:noFill/>
+        </p:spPr>
+        <p:txBody>
+          <a:bodyPr wrap="square" lIns="0" rIns="0" tIns="0" bIns="0" anchor="t">
+            <a:spAutoFit/>
+          </a:bodyPr>
+          <a:lstStyle/>
+          <a:p>
+            <a:pPr algn="l">
+              <a:spcBef>
+                <a:spcPts val="0"/>
+              </a:spcBef>
+              <a:spcAft>
+                <a:spcPts val="0"/>
+              </a:spcAft>
+            </a:pPr>
+            <a:r>
+              <a:rPr sz="710" b="1" i="0">
+                <a:solidFill>
+                  <a:srgbClr val="00B5E2"/>
+                </a:solidFill>
+                <a:latin typeface="Aptos"/>
+                <a:spc val="70"/>
+              </a:rPr>
+              <a:t>FINDING</a:t>
+            </a:r>
+          </a:p>
+        </p:txBody>
+      </p:sp>
+      <p:sp>
+        <p:nvSpPr>
+          <p:cNvPr id="16" name="TextBox 15"/>
+          <p:cNvSpPr txBox="1"/>
+          <p:nvPr/>
+        </p:nvSpPr>
+        <p:spPr>
+          <a:xfrm>
+            <a:off x="667512" y="2697480"/>
+            <a:ext cx="5541264" cy="493776"/>
+          </a:xfrm>
+          <a:prstGeom prst="rect">
+            <a:avLst/>
+          </a:prstGeom>
+          <a:noFill/>
+        </p:spPr>
+        <p:txBody>
+          <a:bodyPr wrap="square" lIns="0" rIns="0" tIns="0" bIns="0" anchor="t">
+            <a:spAutoFit/>
+          </a:bodyPr>
+          <a:lstStyle/>
+          <a:p>
+            <a:pPr algn="l">
+              <a:spcBef>
+                <a:spcPts val="0"/>
+              </a:spcBef>
+              <a:spcAft>
+                <a:spcPts val="0"/>
+              </a:spcAft>
+            </a:pPr>
+            <a:r>
+              <a:rPr sz="1310" b="1" i="0">
+                <a:solidFill>
+                  <a:srgbClr val="F5FAFB"/>
+                </a:solidFill>
+                <a:latin typeface="Aptos Display"/>
+              </a:rPr>
+              <a:t>Workers were observed manually moving the handheld concrete vibrator while it remained switched on and operating.</a:t>
+            </a:r>
+          </a:p>
+        </p:txBody>
+      </p:sp>
+      <p:sp>
+        <p:nvSpPr>
+          <p:cNvPr id="17" name="Rounded Rectangle 16"/>
+          <p:cNvSpPr/>
+          <p:nvPr/>
+        </p:nvSpPr>
+        <p:spPr>
+          <a:xfrm>
+            <a:off x="457200" y="3621024"/>
+            <a:ext cx="6080760" cy="1307592"/>
+          </a:xfrm>
+          <a:prstGeom prst="roundRect">
+            <a:avLst/>
+          </a:prstGeom>
+          <a:solidFill>
+            <a:srgbClr val="1B353B"/>
+          </a:solidFill>
+          <a:ln>
+            <a:noFill/>
+          </a:ln>
+        </p:spPr>
+        <p:style>
+          <a:lnRef idx="1">
+            <a:schemeClr val="accent1"/>
+          </a:lnRef>
+          <a:fillRef idx="3">
+            <a:schemeClr val="accent1"/>
+          </a:fillRef>
+          <a:effectRef idx="2">
+            <a:schemeClr val="accent1"/>
+          </a:effectRef>
+          <a:fontRef idx="minor">
+            <a:schemeClr val="lt1"/>
+          </a:fontRef>
+        </p:style>
+        <p:txBody>
+          <a:bodyPr rtlCol="0" anchor="ctr"/>
+          <a:lstStyle/>
+          <a:p>
+            <a:pPr algn="ctr"/>
+          </a:p>
+        </p:txBody>
+      </p:sp>
+      <p:sp>
+        <p:nvSpPr>
+          <p:cNvPr id="18" name="Rectangle 17"/>
+          <p:cNvSpPr/>
+          <p:nvPr/>
+        </p:nvSpPr>
+        <p:spPr>
+          <a:xfrm>
+            <a:off x="457200" y="3621024"/>
+            <a:ext cx="50292" cy="1307592"/>
+          </a:xfrm>
+          <a:prstGeom prst="rect">
+            <a:avLst/>
+          </a:prstGeom>
+          <a:solidFill>
+            <a:srgbClr val="F3C45D"/>
+          </a:solidFill>
+          <a:ln>
+            <a:noFill/>
+          </a:ln>
+        </p:spPr>
+        <p:style>
+          <a:lnRef idx="1">
+            <a:schemeClr val="accent1"/>
+          </a:lnRef>
+          <a:fillRef idx="3">
+            <a:schemeClr val="accent1"/>
+          </a:fillRef>
+          <a:effectRef idx="2">
+            <a:schemeClr val="accent1"/>
+          </a:effectRef>
+          <a:fontRef idx="minor">
+            <a:schemeClr val="lt1"/>
+          </a:fontRef>
+        </p:style>
+        <p:txBody>
+          <a:bodyPr rtlCol="0" anchor="ctr"/>
+          <a:lstStyle/>
+          <a:p>
+            <a:pPr algn="ctr"/>
+          </a:p>
+        </p:txBody>
+      </p:sp>
+      <p:sp>
+        <p:nvSpPr>
+          <p:cNvPr id="19" name="TextBox 18"/>
+          <p:cNvSpPr txBox="1"/>
+          <p:nvPr/>
+        </p:nvSpPr>
+        <p:spPr>
+          <a:xfrm>
+            <a:off x="658368" y="3785615"/>
+            <a:ext cx="5715000" cy="146304"/>
+          </a:xfrm>
+          <a:prstGeom prst="rect">
+            <a:avLst/>
+          </a:prstGeom>
+          <a:noFill/>
+        </p:spPr>
+        <p:txBody>
+          <a:bodyPr wrap="square" lIns="0" rIns="0" tIns="0" bIns="0" anchor="t">
+            <a:spAutoFit/>
+          </a:bodyPr>
+          <a:lstStyle/>
+          <a:p>
+            <a:pPr algn="l">
+              <a:spcBef>
+                <a:spcPts val="0"/>
+              </a:spcBef>
+              <a:spcAft>
+                <a:spcPts val="0"/>
+              </a:spcAft>
+            </a:pPr>
+            <a:r>
+              <a:rPr sz="720" b="1" i="0">
+                <a:solidFill>
+                  <a:srgbClr val="F3C45D"/>
+                </a:solidFill>
+                <a:latin typeface="Aptos"/>
+                <a:spc val="80"/>
+              </a:rPr>
+              <a:t>KEY QUESTION</a:t>
+            </a:r>
+          </a:p>
+        </p:txBody>
+      </p:sp>
+      <p:sp>
+        <p:nvSpPr>
+          <p:cNvPr id="20" name="TextBox 19"/>
+          <p:cNvSpPr txBox="1"/>
+          <p:nvPr/>
+        </p:nvSpPr>
+        <p:spPr>
+          <a:xfrm>
+            <a:off x="658368" y="3986784"/>
+            <a:ext cx="5696712" cy="832103"/>
+          </a:xfrm>
+          <a:prstGeom prst="rect">
+            <a:avLst/>
+          </a:prstGeom>
+          <a:noFill/>
+        </p:spPr>
+        <p:txBody>
+          <a:bodyPr wrap="square" lIns="0" rIns="0" tIns="0" bIns="0" anchor="t">
+            <a:spAutoFit/>
+          </a:bodyPr>
+          <a:lstStyle/>
+          <a:p>
+            <a:pPr algn="l">
+              <a:spcBef>
+                <a:spcPts val="0"/>
+              </a:spcBef>
+              <a:spcAft>
+                <a:spcPts val="0"/>
+              </a:spcAft>
+            </a:pPr>
+            <a:r>
+              <a:rPr sz="1100" b="1" i="0">
+                <a:solidFill>
+                  <a:srgbClr val="F5FAFB"/>
+                </a:solidFill>
+                <a:latin typeface="Aptos Display"/>
+              </a:rPr>
+              <a:t>Is manual movement of an operating vibrator acceptable without a stop–move–restart control?</a:t>
+            </a:r>
+          </a:p>
+        </p:txBody>
+      </p:sp>
+      <p:sp>
+        <p:nvSpPr>
+          <p:cNvPr id="21" name="Rounded Rectangle 20"/>
+          <p:cNvSpPr/>
+          <p:nvPr/>
+        </p:nvSpPr>
+        <p:spPr>
+          <a:xfrm>
+            <a:off x="6876288" y="1307592"/>
+            <a:ext cx="4846320" cy="3621024"/>
+          </a:xfrm>
+          <a:prstGeom prst="roundRect">
+            <a:avLst/>
+          </a:prstGeom>
+          <a:solidFill>
+            <a:srgbClr val="162429"/>
+          </a:solidFill>
+          <a:ln w="16510">
+            <a:solidFill>
+              <a:srgbClr val="007E8C"/>
+            </a:solidFill>
+          </a:ln>
+        </p:spPr>
+        <p:style>
+          <a:lnRef idx="1">
+            <a:schemeClr val="accent1"/>
+          </a:lnRef>
+          <a:fillRef idx="3">
+            <a:schemeClr val="accent1"/>
+          </a:fillRef>
+          <a:effectRef idx="2">
+            <a:schemeClr val="accent1"/>
+          </a:effectRef>
+          <a:fontRef idx="minor">
+            <a:schemeClr val="lt1"/>
+          </a:fontRef>
+        </p:style>
+        <p:txBody>
+          <a:bodyPr rtlCol="0" anchor="ctr"/>
+          <a:lstStyle/>
+          <a:p>
+            <a:pPr algn="ctr"/>
+          </a:p>
+        </p:txBody>
+      </p:sp>
+      <p:cxnSp>
+        <p:nvCxnSpPr>
+          <p:cNvPr id="22" name="Connector 21"/>
+          <p:cNvCxnSpPr/>
+          <p:nvPr/>
+        </p:nvCxnSpPr>
+        <p:spPr>
+          <a:xfrm>
+            <a:off x="7040879" y="1472184"/>
+            <a:ext cx="4517137" cy="3291840"/>
+          </a:xfrm>
+          <a:prstGeom prst="line">
+            <a:avLst/>
+          </a:prstGeom>
+          <a:ln w="8890">
+            <a:solidFill>
+              <a:srgbClr val="28464C"/>
+            </a:solidFill>
+          </a:ln>
+        </p:spPr>
+        <p:style>
+          <a:lnRef idx="2">
+            <a:schemeClr val="accent1"/>
+          </a:lnRef>
+          <a:fillRef idx="0">
+            <a:schemeClr val="accent1"/>
+          </a:fillRef>
+          <a:effectRef idx="1">
+            <a:schemeClr val="accent1"/>
+          </a:effectRef>
+          <a:fontRef idx="minor">
+            <a:schemeClr val="tx1"/>
+          </a:fontRef>
+        </p:style>
+      </p:cxnSp>
+      <p:cxnSp>
+        <p:nvCxnSpPr>
+          <p:cNvPr id="23" name="Connector 22"/>
+          <p:cNvCxnSpPr/>
+          <p:nvPr/>
+        </p:nvCxnSpPr>
+        <p:spPr>
+          <a:xfrm flipH="1">
+            <a:off x="7040879" y="1472184"/>
+            <a:ext cx="4517137" cy="3291840"/>
+          </a:xfrm>
+          <a:prstGeom prst="line">
+            <a:avLst/>
+          </a:prstGeom>
+          <a:ln w="8890">
+            <a:solidFill>
+              <a:srgbClr val="28464C"/>
+            </a:solidFill>
+          </a:ln>
+        </p:spPr>
+        <p:style>
+          <a:lnRef idx="2">
+            <a:schemeClr val="accent1"/>
+          </a:lnRef>
+          <a:fillRef idx="0">
+            <a:schemeClr val="accent1"/>
+          </a:fillRef>
+          <a:effectRef idx="1">
+            <a:schemeClr val="accent1"/>
+          </a:effectRef>
+          <a:fontRef idx="minor">
+            <a:schemeClr val="tx1"/>
+          </a:fontRef>
+        </p:style>
+      </p:cxnSp>
+      <p:cxnSp>
+        <p:nvCxnSpPr>
+          <p:cNvPr id="24" name="Connector 23"/>
+          <p:cNvCxnSpPr/>
+          <p:nvPr/>
+        </p:nvCxnSpPr>
+        <p:spPr>
+          <a:xfrm>
+            <a:off x="9299448" y="1453895"/>
+            <a:ext cx="0" cy="3328417"/>
+          </a:xfrm>
+          <a:prstGeom prst="line">
+            <a:avLst/>
+          </a:prstGeom>
+          <a:ln w="7620">
+            <a:solidFill>
+              <a:srgbClr val="28464C"/>
+            </a:solidFill>
+          </a:ln>
+        </p:spPr>
+        <p:style>
+          <a:lnRef idx="2">
+            <a:schemeClr val="accent1"/>
+          </a:lnRef>
+          <a:fillRef idx="0">
+            <a:schemeClr val="accent1"/>
+          </a:fillRef>
+          <a:effectRef idx="1">
+            <a:schemeClr val="accent1"/>
+          </a:effectRef>
+          <a:fontRef idx="minor">
+            <a:schemeClr val="tx1"/>
+          </a:fontRef>
+        </p:style>
+      </p:cxnSp>
+      <p:cxnSp>
+        <p:nvCxnSpPr>
+          <p:cNvPr id="25" name="Connector 24"/>
+          <p:cNvCxnSpPr/>
+          <p:nvPr/>
+        </p:nvCxnSpPr>
+        <p:spPr>
+          <a:xfrm>
+            <a:off x="7022592" y="3118104"/>
+            <a:ext cx="4553712" cy="0"/>
+          </a:xfrm>
+          <a:prstGeom prst="line">
+            <a:avLst/>
+          </a:prstGeom>
+          <a:ln w="7620">
+            <a:solidFill>
+              <a:srgbClr val="28464C"/>
+            </a:solidFill>
+          </a:ln>
+        </p:spPr>
+        <p:style>
+          <a:lnRef idx="2">
+            <a:schemeClr val="accent1"/>
+          </a:lnRef>
+          <a:fillRef idx="0">
+            <a:schemeClr val="accent1"/>
+          </a:fillRef>
+          <a:effectRef idx="1">
+            <a:schemeClr val="accent1"/>
+          </a:effectRef>
+          <a:fontRef idx="minor">
+            <a:schemeClr val="tx1"/>
+          </a:fontRef>
+        </p:style>
+      </p:cxnSp>
+      <p:sp>
+        <p:nvSpPr>
+          <p:cNvPr id="26" name="Oval 25"/>
+          <p:cNvSpPr/>
+          <p:nvPr/>
+        </p:nvSpPr>
+        <p:spPr>
+          <a:xfrm>
+            <a:off x="9098280" y="2916936"/>
+            <a:ext cx="402336" cy="402336"/>
+          </a:xfrm>
+          <a:prstGeom prst="ellipse">
+            <a:avLst/>
+          </a:prstGeom>
+          <a:noFill/>
+          <a:ln w="12700">
+            <a:solidFill>
+              <a:srgbClr val="007E8C"/>
+            </a:solidFill>
+          </a:ln>
+        </p:spPr>
+        <p:style>
+          <a:lnRef idx="1">
+            <a:schemeClr val="accent1"/>
+          </a:lnRef>
+          <a:fillRef idx="3">
+            <a:schemeClr val="accent1"/>
+          </a:fillRef>
+          <a:effectRef idx="2">
+            <a:schemeClr val="accent1"/>
+          </a:effectRef>
+          <a:fontRef idx="minor">
+            <a:schemeClr val="lt1"/>
+          </a:fontRef>
+        </p:style>
+        <p:txBody>
+          <a:bodyPr rtlCol="0" anchor="ctr"/>
+          <a:lstStyle/>
+          <a:p>
+            <a:pPr algn="ctr"/>
+          </a:p>
+        </p:txBody>
+      </p:sp>
+      <p:sp>
+        <p:nvSpPr>
+          <p:cNvPr id="27" name="Oval 26"/>
+          <p:cNvSpPr/>
+          <p:nvPr/>
+        </p:nvSpPr>
+        <p:spPr>
+          <a:xfrm>
+            <a:off x="9249156" y="3067812"/>
+            <a:ext cx="100584" cy="100584"/>
+          </a:xfrm>
+          <a:prstGeom prst="ellipse">
+            <a:avLst/>
+          </a:prstGeom>
+          <a:solidFill>
+            <a:srgbClr val="00B5E2"/>
+          </a:solidFill>
+          <a:ln>
+            <a:noFill/>
+          </a:ln>
+        </p:spPr>
+        <p:style>
+          <a:lnRef idx="1">
+            <a:schemeClr val="accent1"/>
+          </a:lnRef>
+          <a:fillRef idx="3">
+            <a:schemeClr val="accent1"/>
+          </a:fillRef>
+          <a:effectRef idx="2">
+            <a:schemeClr val="accent1"/>
+          </a:effectRef>
+          <a:fontRef idx="minor">
+            <a:schemeClr val="lt1"/>
+          </a:fontRef>
+        </p:style>
+        <p:txBody>
+          <a:bodyPr rtlCol="0" anchor="ctr"/>
+          <a:lstStyle/>
+          <a:p>
+            <a:pPr algn="ctr"/>
+          </a:p>
+        </p:txBody>
+      </p:sp>
+      <p:sp>
+        <p:nvSpPr>
+          <p:cNvPr id="28" name="Rectangle 27"/>
+          <p:cNvSpPr/>
+          <p:nvPr/>
+        </p:nvSpPr>
+        <p:spPr>
+          <a:xfrm>
+            <a:off x="7022592" y="1453895"/>
+            <a:ext cx="932688" cy="201168"/>
+          </a:xfrm>
+          <a:prstGeom prst="rect">
+            <a:avLst/>
+          </a:prstGeom>
+          <a:solidFill>
+            <a:srgbClr val="0D171B"/>
+          </a:solidFill>
+          <a:ln>
+            <a:noFill/>
+          </a:ln>
+        </p:spPr>
+        <p:style>
+          <a:lnRef idx="1">
+            <a:schemeClr val="accent1"/>
+          </a:lnRef>
+          <a:fillRef idx="3">
+            <a:schemeClr val="accent1"/>
+          </a:fillRef>
+          <a:effectRef idx="2">
+            <a:schemeClr val="accent1"/>
+          </a:effectRef>
+          <a:fontRef idx="minor">
+            <a:schemeClr val="lt1"/>
+          </a:fontRef>
+        </p:style>
+        <p:txBody>
+          <a:bodyPr rtlCol="0" anchor="ctr"/>
+          <a:lstStyle/>
+          <a:p>
+            <a:pPr algn="ctr"/>
+          </a:p>
+        </p:txBody>
+      </p:sp>
+      <p:sp>
+        <p:nvSpPr>
+          <p:cNvPr id="29" name="TextBox 28"/>
+          <p:cNvSpPr txBox="1"/>
+          <p:nvPr/>
+        </p:nvSpPr>
+        <p:spPr>
+          <a:xfrm>
+            <a:off x="7077455" y="1495044"/>
+            <a:ext cx="822960" cy="100584"/>
+          </a:xfrm>
+          <a:prstGeom prst="rect">
+            <a:avLst/>
+          </a:prstGeom>
+          <a:noFill/>
+        </p:spPr>
+        <p:txBody>
+          <a:bodyPr wrap="square" lIns="0" rIns="0" tIns="0" bIns="0" anchor="t">
+            <a:spAutoFit/>
+          </a:bodyPr>
+          <a:lstStyle/>
+          <a:p>
+            <a:pPr algn="l">
+              <a:spcBef>
+                <a:spcPts val="0"/>
+              </a:spcBef>
+              <a:spcAft>
+                <a:spcPts val="0"/>
+              </a:spcAft>
+            </a:pPr>
+            <a:r>
+              <a:rPr sz="640" b="1" i="0">
+                <a:solidFill>
+                  <a:srgbClr val="00B5E2"/>
+                </a:solidFill>
+                <a:latin typeface="Aptos"/>
+                <a:spc val="55"/>
+              </a:rPr>
+              <a:t>FIELD EVIDENCE</a:t>
+            </a:r>
+          </a:p>
+        </p:txBody>
+      </p:sp>
+      <p:sp>
+        <p:nvSpPr>
+          <p:cNvPr id="30" name="TextBox 29"/>
+          <p:cNvSpPr txBox="1"/>
+          <p:nvPr/>
+        </p:nvSpPr>
+        <p:spPr>
+          <a:xfrm>
+            <a:off x="7077455" y="2999232"/>
+            <a:ext cx="4443983" cy="256032"/>
+          </a:xfrm>
+          <a:prstGeom prst="rect">
+            <a:avLst/>
+          </a:prstGeom>
+          <a:noFill/>
+        </p:spPr>
+        <p:txBody>
+          <a:bodyPr wrap="square" lIns="0" rIns="0" tIns="0" bIns="0" anchor="ctr">
+            <a:spAutoFit/>
+          </a:bodyPr>
+          <a:lstStyle/>
+          <a:p>
+            <a:pPr algn="ctr">
+              <a:spcBef>
+                <a:spcPts val="0"/>
+              </a:spcBef>
+              <a:spcAft>
+                <a:spcPts val="0"/>
+              </a:spcAft>
+            </a:pPr>
+            <a:r>
+              <a:rPr sz="1300" b="1" i="0">
+                <a:solidFill>
+                  <a:srgbClr val="F5FAFB"/>
+                </a:solidFill>
+                <a:latin typeface="Aptos Display"/>
+              </a:rPr>
+              <a:t>[ INSERT PHOTO HERE ]</a:t>
+            </a:r>
+          </a:p>
+        </p:txBody>
+      </p:sp>
+      <p:sp>
+        <p:nvSpPr>
+          <p:cNvPr id="31" name="TextBox 30"/>
+          <p:cNvSpPr txBox="1"/>
+          <p:nvPr/>
+        </p:nvSpPr>
+        <p:spPr>
+          <a:xfrm>
+            <a:off x="7059168" y="4617720"/>
+            <a:ext cx="4480559" cy="164592"/>
+          </a:xfrm>
+          <a:prstGeom prst="rect">
+            <a:avLst/>
+          </a:prstGeom>
+          <a:noFill/>
+        </p:spPr>
+        <p:txBody>
+          <a:bodyPr wrap="square" lIns="0" rIns="0" tIns="0" bIns="0" anchor="t">
+            <a:spAutoFit/>
+          </a:bodyPr>
+          <a:lstStyle/>
+          <a:p>
+            <a:pPr algn="ctr">
+              <a:spcBef>
+                <a:spcPts val="0"/>
+              </a:spcBef>
+              <a:spcAft>
+                <a:spcPts val="0"/>
+              </a:spcAft>
+            </a:pPr>
+            <a:r>
+              <a:rPr sz="730" b="0" i="0">
+                <a:solidFill>
+                  <a:srgbClr val="A9BEC3"/>
+                </a:solidFill>
+                <a:latin typeface="Aptos"/>
+              </a:rPr>
+              <a:t>Vibrator being moved while operating</a:t>
+            </a:r>
+          </a:p>
+        </p:txBody>
+      </p:sp>
+      <p:sp>
+        <p:nvSpPr>
+          <p:cNvPr id="32" name="TextBox 31"/>
+          <p:cNvSpPr txBox="1"/>
+          <p:nvPr/>
+        </p:nvSpPr>
+        <p:spPr>
+          <a:xfrm>
+            <a:off x="6903720" y="5065776"/>
+            <a:ext cx="4754880" cy="137160"/>
+          </a:xfrm>
+          <a:prstGeom prst="rect">
+            <a:avLst/>
+          </a:prstGeom>
+          <a:noFill/>
+        </p:spPr>
+        <p:txBody>
+          <a:bodyPr wrap="square" lIns="0" rIns="0" tIns="0" bIns="0" anchor="t">
+            <a:spAutoFit/>
+          </a:bodyPr>
+          <a:lstStyle/>
+          <a:p>
+            <a:pPr algn="r">
+              <a:spcBef>
+                <a:spcPts val="0"/>
+              </a:spcBef>
+              <a:spcAft>
+                <a:spcPts val="0"/>
+              </a:spcAft>
+            </a:pPr>
+            <a:r>
+              <a:rPr sz="630" b="1" i="0">
+                <a:solidFill>
+                  <a:srgbClr val="6E8B91"/>
+                </a:solidFill>
+                <a:latin typeface="Aptos"/>
+                <a:spc val="45"/>
+              </a:rPr>
+              <a:t>REPLACE WITH SITE PHOTO BEFORE ISSUE</a:t>
+            </a:r>
+          </a:p>
+        </p:txBody>
+      </p:sp>
+      <p:sp>
+        <p:nvSpPr>
+          <p:cNvPr id="33" name="Rounded Rectangle 32"/>
+          <p:cNvSpPr/>
+          <p:nvPr/>
+        </p:nvSpPr>
+        <p:spPr>
+          <a:xfrm>
+            <a:off x="457200" y="5330952"/>
+            <a:ext cx="6080760" cy="749808"/>
+          </a:xfrm>
+          <a:prstGeom prst="roundRect">
+            <a:avLst/>
+          </a:prstGeom>
+          <a:solidFill>
+            <a:srgbClr val="6E2026"/>
+          </a:solidFill>
+          <a:ln>
+            <a:noFill/>
+          </a:ln>
+        </p:spPr>
+        <p:style>
+          <a:lnRef idx="1">
+            <a:schemeClr val="accent1"/>
+          </a:lnRef>
+          <a:fillRef idx="3">
+            <a:schemeClr val="accent1"/>
+          </a:fillRef>
+          <a:effectRef idx="2">
+            <a:schemeClr val="accent1"/>
+          </a:effectRef>
+          <a:fontRef idx="minor">
+            <a:schemeClr val="lt1"/>
+          </a:fontRef>
+        </p:style>
+        <p:txBody>
+          <a:bodyPr rtlCol="0" anchor="ctr"/>
+          <a:lstStyle/>
+          <a:p>
+            <a:pPr algn="ctr"/>
+          </a:p>
+        </p:txBody>
+      </p:sp>
+      <p:sp>
+        <p:nvSpPr>
+          <p:cNvPr id="34" name="TextBox 33"/>
+          <p:cNvSpPr txBox="1"/>
+          <p:nvPr/>
+        </p:nvSpPr>
+        <p:spPr>
+          <a:xfrm>
+            <a:off x="658368" y="5477256"/>
+            <a:ext cx="1280160" cy="137160"/>
+          </a:xfrm>
+          <a:prstGeom prst="rect">
+            <a:avLst/>
+          </a:prstGeom>
+          <a:noFill/>
+        </p:spPr>
+        <p:txBody>
+          <a:bodyPr wrap="square" lIns="0" rIns="0" tIns="0" bIns="0" anchor="t">
+            <a:spAutoFit/>
+          </a:bodyPr>
+          <a:lstStyle/>
+          <a:p>
+            <a:pPr algn="l">
+              <a:spcBef>
+                <a:spcPts val="0"/>
+              </a:spcBef>
+              <a:spcAft>
+                <a:spcPts val="0"/>
+              </a:spcAft>
+            </a:pPr>
+            <a:r>
+              <a:rPr sz="710" b="1" i="0">
+                <a:solidFill>
+                  <a:srgbClr val="F04A4A"/>
+                </a:solidFill>
+                <a:latin typeface="Aptos"/>
+                <a:spc val="75"/>
+              </a:rPr>
+              <a:t>ACTION REQUIRED</a:t>
+            </a:r>
+          </a:p>
+        </p:txBody>
+      </p:sp>
+      <p:sp>
+        <p:nvSpPr>
+          <p:cNvPr id="35" name="TextBox 34"/>
+          <p:cNvSpPr txBox="1"/>
+          <p:nvPr/>
+        </p:nvSpPr>
+        <p:spPr>
+          <a:xfrm>
+            <a:off x="658368" y="5660136"/>
+            <a:ext cx="5715000" cy="274320"/>
+          </a:xfrm>
+          <a:prstGeom prst="rect">
+            <a:avLst/>
+          </a:prstGeom>
+          <a:noFill/>
+        </p:spPr>
+        <p:txBody>
+          <a:bodyPr wrap="square" lIns="0" rIns="0" tIns="0" bIns="0" anchor="t">
+            <a:spAutoFit/>
+          </a:bodyPr>
+          <a:lstStyle/>
+          <a:p>
+            <a:pPr algn="l">
+              <a:spcBef>
+                <a:spcPts val="0"/>
+              </a:spcBef>
+              <a:spcAft>
+                <a:spcPts val="0"/>
+              </a:spcAft>
+            </a:pPr>
+            <a:r>
+              <a:rPr sz="1060" b="1" i="0">
+                <a:solidFill>
+                  <a:srgbClr val="F5FAFB"/>
+                </a:solidFill>
+                <a:latin typeface="Aptos Display"/>
+              </a:rPr>
+              <a:t>Stop the vibrator before relocation or handover. Apply a controlled stop–move–restart procedure and brief all operators.</a:t>
+            </a:r>
+          </a:p>
+        </p:txBody>
+      </p:sp>
+      <p:sp>
+        <p:nvSpPr>
+          <p:cNvPr id="36" name="TextBox 35"/>
+          <p:cNvSpPr txBox="1"/>
+          <p:nvPr/>
+        </p:nvSpPr>
+        <p:spPr>
+          <a:xfrm>
+            <a:off x="457200" y="6236208"/>
+            <a:ext cx="411480" cy="118872"/>
+          </a:xfrm>
+          <a:prstGeom prst="rect">
+            <a:avLst/>
+          </a:prstGeom>
+          <a:noFill/>
+        </p:spPr>
+        <p:txBody>
+          <a:bodyPr wrap="square" lIns="0" rIns="0" tIns="0" bIns="0" anchor="t">
+            <a:spAutoFit/>
+          </a:bodyPr>
+          <a:lstStyle/>
+          <a:p>
+            <a:pPr algn="l">
+              <a:spcBef>
+                <a:spcPts val="0"/>
+              </a:spcBef>
+              <a:spcAft>
+                <a:spcPts val="0"/>
+              </a:spcAft>
+            </a:pPr>
+            <a:r>
+              <a:rPr sz="660" b="1" i="0">
+                <a:solidFill>
+                  <a:srgbClr val="6E8B91"/>
+                </a:solidFill>
+                <a:latin typeface="Aptos"/>
+                <a:spc val="70"/>
+              </a:rPr>
+              <a:t>OWNER</a:t>
+            </a:r>
+          </a:p>
+        </p:txBody>
+      </p:sp>
+      <p:sp>
+        <p:nvSpPr>
+          <p:cNvPr id="37" name="TextBox 36"/>
+          <p:cNvSpPr txBox="1"/>
+          <p:nvPr/>
+        </p:nvSpPr>
+        <p:spPr>
+          <a:xfrm>
+            <a:off x="932688" y="6217920"/>
+            <a:ext cx="2148840" cy="155448"/>
+          </a:xfrm>
+          <a:prstGeom prst="rect">
+            <a:avLst/>
+          </a:prstGeom>
+          <a:noFill/>
+        </p:spPr>
+        <p:txBody>
+          <a:bodyPr wrap="square" lIns="0" rIns="0" tIns="0" bIns="0" anchor="t">
+            <a:spAutoFit/>
+          </a:bodyPr>
+          <a:lstStyle/>
+          <a:p>
+            <a:pPr algn="l">
+              <a:spcBef>
+                <a:spcPts val="0"/>
+              </a:spcBef>
+              <a:spcAft>
+                <a:spcPts val="0"/>
+              </a:spcAft>
+            </a:pPr>
+            <a:r>
+              <a:rPr sz="770" b="1" i="0">
+                <a:solidFill>
+                  <a:srgbClr val="F5FAFB"/>
+                </a:solidFill>
+                <a:latin typeface="Aptos"/>
+              </a:rPr>
+              <a:t>Concrete Subcontractor / Supervisor</a:t>
+            </a:r>
+          </a:p>
+        </p:txBody>
+      </p:sp>
+      <p:sp>
+        <p:nvSpPr>
+          <p:cNvPr id="38" name="TextBox 37"/>
+          <p:cNvSpPr txBox="1"/>
+          <p:nvPr/>
+        </p:nvSpPr>
+        <p:spPr>
+          <a:xfrm>
+            <a:off x="3456432" y="6236208"/>
+            <a:ext cx="411480" cy="118872"/>
+          </a:xfrm>
+          <a:prstGeom prst="rect">
+            <a:avLst/>
+          </a:prstGeom>
+          <a:noFill/>
+        </p:spPr>
+        <p:txBody>
+          <a:bodyPr wrap="square" lIns="0" rIns="0" tIns="0" bIns="0" anchor="t">
+            <a:spAutoFit/>
+          </a:bodyPr>
+          <a:lstStyle/>
+          <a:p>
+            <a:pPr algn="l">
+              <a:spcBef>
+                <a:spcPts val="0"/>
+              </a:spcBef>
+              <a:spcAft>
+                <a:spcPts val="0"/>
+              </a:spcAft>
+            </a:pPr>
+            <a:r>
+              <a:rPr sz="660" b="1" i="0">
+                <a:solidFill>
+                  <a:srgbClr val="6E8B91"/>
+                </a:solidFill>
+                <a:latin typeface="Aptos"/>
+                <a:spc val="70"/>
+              </a:rPr>
+              <a:t>CLOSE</a:t>
+            </a:r>
+          </a:p>
+        </p:txBody>
+      </p:sp>
+      <p:sp>
+        <p:nvSpPr>
+          <p:cNvPr id="39" name="TextBox 38"/>
+          <p:cNvSpPr txBox="1"/>
+          <p:nvPr/>
+        </p:nvSpPr>
+        <p:spPr>
+          <a:xfrm>
+            <a:off x="3931920" y="6217920"/>
+            <a:ext cx="2606040" cy="155448"/>
+          </a:xfrm>
+          <a:prstGeom prst="rect">
+            <a:avLst/>
+          </a:prstGeom>
+          <a:noFill/>
+        </p:spPr>
+        <p:txBody>
+          <a:bodyPr wrap="square" lIns="0" rIns="0" tIns="0" bIns="0" anchor="t">
+            <a:spAutoFit/>
+          </a:bodyPr>
+          <a:lstStyle/>
+          <a:p>
+            <a:pPr algn="l">
+              <a:spcBef>
+                <a:spcPts val="0"/>
+              </a:spcBef>
+              <a:spcAft>
+                <a:spcPts val="0"/>
+              </a:spcAft>
+            </a:pPr>
+            <a:r>
+              <a:rPr sz="770" b="1" i="0">
+                <a:solidFill>
+                  <a:srgbClr val="F5FAFB"/>
+                </a:solidFill>
+                <a:latin typeface="Aptos"/>
+              </a:rPr>
+              <a:t>Immediate / before next pour</a:t>
+            </a:r>
+          </a:p>
+        </p:txBody>
+      </p:sp>
+    </p:spTree>
+  </p:cSld>
+  <p:clrMapOvr>
+    <a:masterClrMapping/>
+  </p:clrMapOvr>
+</p:sld>
+</file>
+
+<file path=ppt/slides/slide11.xml><?xml version="1.0" encoding="utf-8"?>
+<p:sld xmlns:a="http://schemas.openxmlformats.org/drawingml/2006/main" xmlns:p="http://schemas.openxmlformats.org/presentationml/2006/main" xmlns:r="http://schemas.openxmlformats.org/officeDocument/2006/relationships">
+  <p:cSld>
+    <p:bg>
+      <p:bgPr>
+        <a:solidFill>
+          <a:srgbClr val="0D171B"/>
+        </a:solidFill>
+        <a:effectLst/>
+      </p:bgPr>
+    </p:bg>
+    <p:spTree>
+      <p:nvGrpSpPr>
+        <p:cNvPr id="1" name=""/>
+        <p:cNvGrpSpPr/>
+        <p:nvPr/>
+      </p:nvGrpSpPr>
+      <p:grpSpPr/>
+      <p:sp>
+        <p:nvSpPr>
+          <p:cNvPr id="2" name="Rectangle 1"/>
+          <p:cNvSpPr/>
+          <p:nvPr/>
+        </p:nvSpPr>
+        <p:spPr>
+          <a:xfrm>
+            <a:off x="0" y="0"/>
+            <a:ext cx="12191695" cy="50292"/>
+          </a:xfrm>
+          <a:prstGeom prst="rect">
+            <a:avLst/>
+          </a:prstGeom>
+          <a:solidFill>
+            <a:srgbClr val="00B5E2"/>
+          </a:solidFill>
+          <a:ln>
+            <a:noFill/>
+          </a:ln>
+        </p:spPr>
+        <p:style>
+          <a:lnRef idx="1">
+            <a:schemeClr val="accent1"/>
+          </a:lnRef>
+          <a:fillRef idx="3">
+            <a:schemeClr val="accent1"/>
+          </a:fillRef>
+          <a:effectRef idx="2">
+            <a:schemeClr val="accent1"/>
+          </a:effectRef>
+          <a:fontRef idx="minor">
+            <a:schemeClr val="lt1"/>
+          </a:fontRef>
+        </p:style>
+        <p:txBody>
+          <a:bodyPr rtlCol="0" anchor="ctr"/>
+          <a:lstStyle/>
+          <a:p>
+            <a:pPr algn="ctr"/>
+          </a:p>
+        </p:txBody>
+      </p:sp>
+      <p:sp>
+        <p:nvSpPr>
+          <p:cNvPr id="3" name="TextBox 2"/>
+          <p:cNvSpPr txBox="1"/>
+          <p:nvPr/>
+        </p:nvSpPr>
+        <p:spPr>
+          <a:xfrm>
+            <a:off x="438912" y="164592"/>
+            <a:ext cx="2194560" cy="182880"/>
+          </a:xfrm>
+          <a:prstGeom prst="rect">
+            <a:avLst/>
+          </a:prstGeom>
+          <a:noFill/>
+        </p:spPr>
+        <p:txBody>
+          <a:bodyPr wrap="square" lIns="0" rIns="0" tIns="0" bIns="0" anchor="t">
+            <a:spAutoFit/>
+          </a:bodyPr>
+          <a:lstStyle/>
+          <a:p>
+            <a:pPr algn="l">
+              <a:spcBef>
+                <a:spcPts val="0"/>
+              </a:spcBef>
+              <a:spcAft>
+                <a:spcPts val="0"/>
+              </a:spcAft>
+            </a:pPr>
+            <a:r>
+              <a:rPr sz="720" b="1" i="0">
+                <a:solidFill>
+                  <a:srgbClr val="00B5E2"/>
+                </a:solidFill>
+                <a:latin typeface="Aptos"/>
+                <a:spc val="90"/>
+              </a:rPr>
+              <a:t>EHS / NIGHT SHIFT</a:t>
+            </a:r>
+          </a:p>
+        </p:txBody>
+      </p:sp>
+      <p:pic>
+        <p:nvPicPr>
+          <p:cNvPr id="4" name="Picture 3" descr="siemens_energy_logo.png"/>
+          <p:cNvPicPr>
+            <a:picLocks noChangeAspect="1"/>
+          </p:cNvPicPr>
+          <p:nvPr/>
+        </p:nvPicPr>
+        <p:blipFill>
+          <a:blip r:embed="rId2"/>
+          <a:stretch>
+            <a:fillRect/>
+          </a:stretch>
+        </p:blipFill>
+        <p:spPr>
+          <a:xfrm>
+            <a:off x="10579608" y="173736"/>
+            <a:ext cx="1325880" cy="301752"/>
+          </a:xfrm>
+          <a:prstGeom prst="rect">
+            <a:avLst/>
+          </a:prstGeom>
+        </p:spPr>
+      </p:pic>
+      <p:cxnSp>
+        <p:nvCxnSpPr>
+          <p:cNvPr id="5" name="Connector 4"/>
+          <p:cNvCxnSpPr/>
+          <p:nvPr/>
+        </p:nvCxnSpPr>
+        <p:spPr>
+          <a:xfrm>
+            <a:off x="438912" y="612648"/>
+            <a:ext cx="11320272" cy="0"/>
+          </a:xfrm>
+          <a:prstGeom prst="line">
+            <a:avLst/>
+          </a:prstGeom>
+          <a:ln w="10160">
+            <a:solidFill>
+              <a:srgbClr val="28464C"/>
+            </a:solidFill>
+          </a:ln>
+        </p:spPr>
+        <p:style>
+          <a:lnRef idx="2">
+            <a:schemeClr val="accent1"/>
+          </a:lnRef>
+          <a:fillRef idx="0">
+            <a:schemeClr val="accent1"/>
+          </a:fillRef>
+          <a:effectRef idx="1">
+            <a:schemeClr val="accent1"/>
+          </a:effectRef>
+          <a:fontRef idx="minor">
+            <a:schemeClr val="tx1"/>
+          </a:fontRef>
+        </p:style>
+      </p:cxnSp>
+      <p:sp>
+        <p:nvSpPr>
+          <p:cNvPr id="6" name="TextBox 5"/>
+          <p:cNvSpPr txBox="1"/>
+          <p:nvPr/>
+        </p:nvSpPr>
+        <p:spPr>
+          <a:xfrm>
+            <a:off x="438912" y="6510528"/>
+            <a:ext cx="3200400" cy="146304"/>
+          </a:xfrm>
+          <a:prstGeom prst="rect">
+            <a:avLst/>
+          </a:prstGeom>
+          <a:noFill/>
+        </p:spPr>
+        <p:txBody>
+          <a:bodyPr wrap="square" lIns="0" rIns="0" tIns="0" bIns="0" anchor="t">
+            <a:spAutoFit/>
+          </a:bodyPr>
+          <a:lstStyle/>
+          <a:p>
+            <a:pPr algn="l">
+              <a:spcBef>
+                <a:spcPts val="0"/>
+              </a:spcBef>
+              <a:spcAft>
+                <a:spcPts val="0"/>
+              </a:spcAft>
+            </a:pPr>
+            <a:r>
+              <a:rPr sz="680" b="1" i="0">
+                <a:solidFill>
+                  <a:srgbClr val="6E8B91"/>
+                </a:solidFill>
+                <a:latin typeface="Aptos"/>
+                <a:spc val="80"/>
+              </a:rPr>
               <a:t>SUMMARY / IMMEDIATE ACTION PLAN</a:t>
             </a:r>
           </a:p>
@@ -5351,7 +6946,7 @@
         <p:spPr>
           <a:xfrm>
             <a:off x="457200" y="2542032"/>
-            <a:ext cx="8558784" cy="429768"/>
+            <a:ext cx="8558784" cy="365760"/>
           </a:xfrm>
           <a:prstGeom prst="rect">
             <a:avLst/>
@@ -5605,8 +7200,8 @@
         </p:nvSpPr>
         <p:spPr>
           <a:xfrm>
-            <a:off x="457200" y="2971800"/>
-            <a:ext cx="8558784" cy="429768"/>
+            <a:off x="457200" y="2907792"/>
+            <a:ext cx="8558784" cy="365760"/>
           </a:xfrm>
           <a:prstGeom prst="rect">
             <a:avLst/>
@@ -5650,7 +7245,7 @@
         </p:nvSpPr>
         <p:spPr>
           <a:xfrm>
-            <a:off x="530352" y="3118104"/>
+            <a:off x="530352" y="3054096"/>
             <a:ext cx="237744" cy="155448"/>
           </a:xfrm>
           <a:prstGeom prst="rect">
@@ -5692,7 +7287,7 @@
         </p:nvSpPr>
         <p:spPr>
           <a:xfrm>
-            <a:off x="914399" y="3118104"/>
+            <a:off x="914399" y="3054096"/>
             <a:ext cx="3163824" cy="155448"/>
           </a:xfrm>
           <a:prstGeom prst="rect">
@@ -5734,7 +7329,7 @@
         </p:nvSpPr>
         <p:spPr>
           <a:xfrm>
-            <a:off x="4224528" y="3118104"/>
+            <a:off x="4224528" y="3054096"/>
             <a:ext cx="950976" cy="155448"/>
           </a:xfrm>
           <a:prstGeom prst="rect">
@@ -5776,7 +7371,7 @@
         </p:nvSpPr>
         <p:spPr>
           <a:xfrm>
-            <a:off x="5321808" y="3118104"/>
+            <a:off x="5321808" y="3054096"/>
             <a:ext cx="1901952" cy="155448"/>
           </a:xfrm>
           <a:prstGeom prst="rect">
@@ -5818,7 +7413,7 @@
         </p:nvSpPr>
         <p:spPr>
           <a:xfrm>
-            <a:off x="7370064" y="3118104"/>
+            <a:off x="7370064" y="3054096"/>
             <a:ext cx="1572768" cy="155448"/>
           </a:xfrm>
           <a:prstGeom prst="rect">
@@ -5860,8 +7455,8 @@
         </p:nvSpPr>
         <p:spPr>
           <a:xfrm>
-            <a:off x="457200" y="3401568"/>
-            <a:ext cx="8558784" cy="429768"/>
+            <a:off x="457200" y="3273552"/>
+            <a:ext cx="8558784" cy="365760"/>
           </a:xfrm>
           <a:prstGeom prst="rect">
             <a:avLst/>
@@ -5905,7 +7500,7 @@
         </p:nvSpPr>
         <p:spPr>
           <a:xfrm>
-            <a:off x="530352" y="3547872"/>
+            <a:off x="530352" y="3419856"/>
             <a:ext cx="237744" cy="155448"/>
           </a:xfrm>
           <a:prstGeom prst="rect">
@@ -5947,7 +7542,7 @@
         </p:nvSpPr>
         <p:spPr>
           <a:xfrm>
-            <a:off x="914399" y="3547872"/>
+            <a:off x="914399" y="3419856"/>
             <a:ext cx="3163824" cy="155448"/>
           </a:xfrm>
           <a:prstGeom prst="rect">
@@ -5989,7 +7584,7 @@
         </p:nvSpPr>
         <p:spPr>
           <a:xfrm>
-            <a:off x="4224528" y="3547872"/>
+            <a:off x="4224528" y="3419856"/>
             <a:ext cx="950976" cy="155448"/>
           </a:xfrm>
           <a:prstGeom prst="rect">
@@ -6031,7 +7626,7 @@
         </p:nvSpPr>
         <p:spPr>
           <a:xfrm>
-            <a:off x="5321808" y="3547872"/>
+            <a:off x="5321808" y="3419856"/>
             <a:ext cx="1901952" cy="155448"/>
           </a:xfrm>
           <a:prstGeom prst="rect">
@@ -6073,7 +7668,7 @@
         </p:nvSpPr>
         <p:spPr>
           <a:xfrm>
-            <a:off x="7370064" y="3547872"/>
+            <a:off x="7370064" y="3419856"/>
             <a:ext cx="1572768" cy="155448"/>
           </a:xfrm>
           <a:prstGeom prst="rect">
@@ -6115,8 +7710,8 @@
         </p:nvSpPr>
         <p:spPr>
           <a:xfrm>
-            <a:off x="457200" y="3831336"/>
-            <a:ext cx="8558784" cy="429768"/>
+            <a:off x="457200" y="3639312"/>
+            <a:ext cx="8558784" cy="365760"/>
           </a:xfrm>
           <a:prstGeom prst="rect">
             <a:avLst/>
@@ -6160,7 +7755,7 @@
         </p:nvSpPr>
         <p:spPr>
           <a:xfrm>
-            <a:off x="530352" y="3977640"/>
+            <a:off x="530352" y="3785616"/>
             <a:ext cx="237744" cy="155448"/>
           </a:xfrm>
           <a:prstGeom prst="rect">
@@ -6202,7 +7797,7 @@
         </p:nvSpPr>
         <p:spPr>
           <a:xfrm>
-            <a:off x="914399" y="3977640"/>
+            <a:off x="914399" y="3785616"/>
             <a:ext cx="3163824" cy="155448"/>
           </a:xfrm>
           <a:prstGeom prst="rect">
@@ -6244,7 +7839,7 @@
         </p:nvSpPr>
         <p:spPr>
           <a:xfrm>
-            <a:off x="4224528" y="3977640"/>
+            <a:off x="4224528" y="3785616"/>
             <a:ext cx="950976" cy="155448"/>
           </a:xfrm>
           <a:prstGeom prst="rect">
@@ -6286,7 +7881,7 @@
         </p:nvSpPr>
         <p:spPr>
           <a:xfrm>
-            <a:off x="5321808" y="3977640"/>
+            <a:off x="5321808" y="3785616"/>
             <a:ext cx="1901952" cy="155448"/>
           </a:xfrm>
           <a:prstGeom prst="rect">
@@ -6328,7 +7923,7 @@
         </p:nvSpPr>
         <p:spPr>
           <a:xfrm>
-            <a:off x="7370064" y="3977640"/>
+            <a:off x="7370064" y="3785616"/>
             <a:ext cx="1572768" cy="155448"/>
           </a:xfrm>
           <a:prstGeom prst="rect">
@@ -6370,8 +7965,8 @@
         </p:nvSpPr>
         <p:spPr>
           <a:xfrm>
-            <a:off x="457200" y="4261104"/>
-            <a:ext cx="8558784" cy="429768"/>
+            <a:off x="457200" y="4005072"/>
+            <a:ext cx="8558784" cy="365760"/>
           </a:xfrm>
           <a:prstGeom prst="rect">
             <a:avLst/>
@@ -6415,7 +8010,7 @@
         </p:nvSpPr>
         <p:spPr>
           <a:xfrm>
-            <a:off x="530352" y="4407408"/>
+            <a:off x="530352" y="4151376"/>
             <a:ext cx="237744" cy="155448"/>
           </a:xfrm>
           <a:prstGeom prst="rect">
@@ -6457,7 +8052,7 @@
         </p:nvSpPr>
         <p:spPr>
           <a:xfrm>
-            <a:off x="914399" y="4407408"/>
+            <a:off x="914399" y="4151376"/>
             <a:ext cx="3163824" cy="155448"/>
           </a:xfrm>
           <a:prstGeom prst="rect">
@@ -6499,7 +8094,7 @@
         </p:nvSpPr>
         <p:spPr>
           <a:xfrm>
-            <a:off x="4224528" y="4407408"/>
+            <a:off x="4224528" y="4151376"/>
             <a:ext cx="950976" cy="155448"/>
           </a:xfrm>
           <a:prstGeom prst="rect">
@@ -6541,7 +8136,7 @@
         </p:nvSpPr>
         <p:spPr>
           <a:xfrm>
-            <a:off x="5321808" y="4407408"/>
+            <a:off x="5321808" y="4151376"/>
             <a:ext cx="1901952" cy="155448"/>
           </a:xfrm>
           <a:prstGeom prst="rect">
@@ -6583,7 +8178,7 @@
         </p:nvSpPr>
         <p:spPr>
           <a:xfrm>
-            <a:off x="7370064" y="4407408"/>
+            <a:off x="7370064" y="4151376"/>
             <a:ext cx="1572768" cy="155448"/>
           </a:xfrm>
           <a:prstGeom prst="rect">
@@ -6625,8 +8220,8 @@
         </p:nvSpPr>
         <p:spPr>
           <a:xfrm>
-            <a:off x="457200" y="4690872"/>
-            <a:ext cx="8558784" cy="429768"/>
+            <a:off x="457200" y="4370832"/>
+            <a:ext cx="8558784" cy="365760"/>
           </a:xfrm>
           <a:prstGeom prst="rect">
             <a:avLst/>
@@ -6670,7 +8265,7 @@
         </p:nvSpPr>
         <p:spPr>
           <a:xfrm>
-            <a:off x="530352" y="4837176"/>
+            <a:off x="530352" y="4517136"/>
             <a:ext cx="237744" cy="155448"/>
           </a:xfrm>
           <a:prstGeom prst="rect">
@@ -6712,7 +8307,7 @@
         </p:nvSpPr>
         <p:spPr>
           <a:xfrm>
-            <a:off x="914399" y="4837176"/>
+            <a:off x="914399" y="4517136"/>
             <a:ext cx="3163824" cy="155448"/>
           </a:xfrm>
           <a:prstGeom prst="rect">
@@ -6754,7 +8349,7 @@
         </p:nvSpPr>
         <p:spPr>
           <a:xfrm>
-            <a:off x="4224528" y="4837176"/>
+            <a:off x="4224528" y="4517136"/>
             <a:ext cx="950976" cy="155448"/>
           </a:xfrm>
           <a:prstGeom prst="rect">
@@ -6796,7 +8391,7 @@
         </p:nvSpPr>
         <p:spPr>
           <a:xfrm>
-            <a:off x="5321808" y="4837176"/>
+            <a:off x="5321808" y="4517136"/>
             <a:ext cx="1901952" cy="155448"/>
           </a:xfrm>
           <a:prstGeom prst="rect">
@@ -6838,7 +8433,7 @@
         </p:nvSpPr>
         <p:spPr>
           <a:xfrm>
-            <a:off x="7370064" y="4837176"/>
+            <a:off x="7370064" y="4517136"/>
             <a:ext cx="1572768" cy="155448"/>
           </a:xfrm>
           <a:prstGeom prst="rect">
@@ -6880,8 +8475,8 @@
         </p:nvSpPr>
         <p:spPr>
           <a:xfrm>
-            <a:off x="457200" y="5120640"/>
-            <a:ext cx="8558784" cy="429768"/>
+            <a:off x="457200" y="4736592"/>
+            <a:ext cx="8558784" cy="365760"/>
           </a:xfrm>
           <a:prstGeom prst="rect">
             <a:avLst/>
@@ -6925,7 +8520,7 @@
         </p:nvSpPr>
         <p:spPr>
           <a:xfrm>
-            <a:off x="530352" y="5266944"/>
+            <a:off x="530352" y="4882896"/>
             <a:ext cx="237744" cy="155448"/>
           </a:xfrm>
           <a:prstGeom prst="rect">
@@ -6967,7 +8562,7 @@
         </p:nvSpPr>
         <p:spPr>
           <a:xfrm>
-            <a:off x="914399" y="5266944"/>
+            <a:off x="914399" y="4882896"/>
             <a:ext cx="3163824" cy="155448"/>
           </a:xfrm>
           <a:prstGeom prst="rect">
@@ -7009,7 +8604,7 @@
         </p:nvSpPr>
         <p:spPr>
           <a:xfrm>
-            <a:off x="4224528" y="5266944"/>
+            <a:off x="4224528" y="4882896"/>
             <a:ext cx="950976" cy="155448"/>
           </a:xfrm>
           <a:prstGeom prst="rect">
@@ -7051,7 +8646,7 @@
         </p:nvSpPr>
         <p:spPr>
           <a:xfrm>
-            <a:off x="5321808" y="5266944"/>
+            <a:off x="5321808" y="4882896"/>
             <a:ext cx="1901952" cy="155448"/>
           </a:xfrm>
           <a:prstGeom prst="rect">
@@ -7093,7 +8688,7 @@
         </p:nvSpPr>
         <p:spPr>
           <a:xfrm>
-            <a:off x="7370064" y="5266944"/>
+            <a:off x="7370064" y="4882896"/>
             <a:ext cx="1572768" cy="155448"/>
           </a:xfrm>
           <a:prstGeom prst="rect">
@@ -7129,7 +8724,262 @@
       </p:sp>
       <p:sp>
         <p:nvSpPr>
-          <p:cNvPr id="59" name="Rounded Rectangle 58"/>
+          <p:cNvPr id="59" name="Rectangle 58"/>
+          <p:cNvSpPr/>
+          <p:nvPr/>
+        </p:nvSpPr>
+        <p:spPr>
+          <a:xfrm>
+            <a:off x="457200" y="5102352"/>
+            <a:ext cx="8558784" cy="365760"/>
+          </a:xfrm>
+          <a:prstGeom prst="rect">
+            <a:avLst/>
+          </a:prstGeom>
+          <a:solidFill>
+            <a:srgbClr val="122328"/>
+          </a:solidFill>
+          <a:ln w="6350">
+            <a:solidFill>
+              <a:srgbClr val="28464C"/>
+            </a:solidFill>
+          </a:ln>
+        </p:spPr>
+        <p:style>
+          <a:lnRef idx="1">
+            <a:schemeClr val="accent1"/>
+          </a:lnRef>
+          <a:fillRef idx="3">
+            <a:schemeClr val="accent1"/>
+          </a:fillRef>
+          <a:effectRef idx="2">
+            <a:schemeClr val="accent1"/>
+          </a:effectRef>
+          <a:fontRef idx="minor">
+            <a:schemeClr val="lt1"/>
+          </a:fontRef>
+        </p:style>
+        <p:txBody>
+          <a:bodyPr rtlCol="0" anchor="ctr"/>
+          <a:lstStyle/>
+          <a:p>
+            <a:pPr algn="ctr"/>
+          </a:p>
+        </p:txBody>
+      </p:sp>
+      <p:sp>
+        <p:nvSpPr>
+          <p:cNvPr id="60" name="TextBox 59"/>
+          <p:cNvSpPr txBox="1"/>
+          <p:nvPr/>
+        </p:nvSpPr>
+        <p:spPr>
+          <a:xfrm>
+            <a:off x="530352" y="5248656"/>
+            <a:ext cx="237744" cy="155448"/>
+          </a:xfrm>
+          <a:prstGeom prst="rect">
+            <a:avLst/>
+          </a:prstGeom>
+          <a:noFill/>
+        </p:spPr>
+        <p:txBody>
+          <a:bodyPr wrap="square" lIns="0" rIns="0" tIns="0" bIns="0" anchor="t">
+            <a:spAutoFit/>
+          </a:bodyPr>
+          <a:lstStyle/>
+          <a:p>
+            <a:pPr algn="ctr">
+              <a:spcBef>
+                <a:spcPts val="0"/>
+              </a:spcBef>
+              <a:spcAft>
+                <a:spcPts val="0"/>
+              </a:spcAft>
+            </a:pPr>
+            <a:r>
+              <a:rPr sz="780" b="1" i="0">
+                <a:solidFill>
+                  <a:srgbClr val="F5FAFB"/>
+                </a:solidFill>
+                <a:latin typeface="Aptos"/>
+              </a:rPr>
+              <a:t>08</a:t>
+            </a:r>
+          </a:p>
+        </p:txBody>
+      </p:sp>
+      <p:sp>
+        <p:nvSpPr>
+          <p:cNvPr id="61" name="TextBox 60"/>
+          <p:cNvSpPr txBox="1"/>
+          <p:nvPr/>
+        </p:nvSpPr>
+        <p:spPr>
+          <a:xfrm>
+            <a:off x="914399" y="5248656"/>
+            <a:ext cx="3163824" cy="155448"/>
+          </a:xfrm>
+          <a:prstGeom prst="rect">
+            <a:avLst/>
+          </a:prstGeom>
+          <a:noFill/>
+        </p:spPr>
+        <p:txBody>
+          <a:bodyPr wrap="square" lIns="0" rIns="0" tIns="0" bIns="0" anchor="t">
+            <a:spAutoFit/>
+          </a:bodyPr>
+          <a:lstStyle/>
+          <a:p>
+            <a:pPr algn="l">
+              <a:spcBef>
+                <a:spcPts val="0"/>
+              </a:spcBef>
+              <a:spcAft>
+                <a:spcPts val="0"/>
+              </a:spcAft>
+            </a:pPr>
+            <a:r>
+              <a:rPr sz="800" b="1" i="0">
+                <a:solidFill>
+                  <a:srgbClr val="F5FAFB"/>
+                </a:solidFill>
+                <a:latin typeface="Aptos"/>
+              </a:rPr>
+              <a:t>Vibrator moved while operating</a:t>
+            </a:r>
+          </a:p>
+        </p:txBody>
+      </p:sp>
+      <p:sp>
+        <p:nvSpPr>
+          <p:cNvPr id="62" name="TextBox 61"/>
+          <p:cNvSpPr txBox="1"/>
+          <p:nvPr/>
+        </p:nvSpPr>
+        <p:spPr>
+          <a:xfrm>
+            <a:off x="4224528" y="5248656"/>
+            <a:ext cx="950976" cy="155448"/>
+          </a:xfrm>
+          <a:prstGeom prst="rect">
+            <a:avLst/>
+          </a:prstGeom>
+          <a:noFill/>
+        </p:spPr>
+        <p:txBody>
+          <a:bodyPr wrap="square" lIns="0" rIns="0" tIns="0" bIns="0" anchor="t">
+            <a:spAutoFit/>
+          </a:bodyPr>
+          <a:lstStyle/>
+          <a:p>
+            <a:pPr algn="l">
+              <a:spcBef>
+                <a:spcPts val="0"/>
+              </a:spcBef>
+              <a:spcAft>
+                <a:spcPts val="0"/>
+              </a:spcAft>
+            </a:pPr>
+            <a:r>
+              <a:rPr sz="780" b="1" i="0">
+                <a:solidFill>
+                  <a:srgbClr val="F3C45D"/>
+                </a:solidFill>
+                <a:latin typeface="Aptos"/>
+              </a:rPr>
+              <a:t>HIGH</a:t>
+            </a:r>
+          </a:p>
+        </p:txBody>
+      </p:sp>
+      <p:sp>
+        <p:nvSpPr>
+          <p:cNvPr id="63" name="TextBox 62"/>
+          <p:cNvSpPr txBox="1"/>
+          <p:nvPr/>
+        </p:nvSpPr>
+        <p:spPr>
+          <a:xfrm>
+            <a:off x="5321808" y="5248656"/>
+            <a:ext cx="1901952" cy="155448"/>
+          </a:xfrm>
+          <a:prstGeom prst="rect">
+            <a:avLst/>
+          </a:prstGeom>
+          <a:noFill/>
+        </p:spPr>
+        <p:txBody>
+          <a:bodyPr wrap="square" lIns="0" rIns="0" tIns="0" bIns="0" anchor="t">
+            <a:spAutoFit/>
+          </a:bodyPr>
+          <a:lstStyle/>
+          <a:p>
+            <a:pPr algn="l">
+              <a:spcBef>
+                <a:spcPts val="0"/>
+              </a:spcBef>
+              <a:spcAft>
+                <a:spcPts val="0"/>
+              </a:spcAft>
+            </a:pPr>
+            <a:r>
+              <a:rPr sz="780" b="0" i="0">
+                <a:solidFill>
+                  <a:srgbClr val="F5FAFB"/>
+                </a:solidFill>
+                <a:latin typeface="Aptos"/>
+              </a:rPr>
+              <a:t>Concrete Subcontractor</a:t>
+            </a:r>
+          </a:p>
+        </p:txBody>
+      </p:sp>
+      <p:sp>
+        <p:nvSpPr>
+          <p:cNvPr id="64" name="TextBox 63"/>
+          <p:cNvSpPr txBox="1"/>
+          <p:nvPr/>
+        </p:nvSpPr>
+        <p:spPr>
+          <a:xfrm>
+            <a:off x="7370064" y="5248656"/>
+            <a:ext cx="1572768" cy="155448"/>
+          </a:xfrm>
+          <a:prstGeom prst="rect">
+            <a:avLst/>
+          </a:prstGeom>
+          <a:noFill/>
+        </p:spPr>
+        <p:txBody>
+          <a:bodyPr wrap="square" lIns="0" rIns="0" tIns="0" bIns="0" anchor="t">
+            <a:spAutoFit/>
+          </a:bodyPr>
+          <a:lstStyle/>
+          <a:p>
+            <a:pPr algn="l">
+              <a:spcBef>
+                <a:spcPts val="0"/>
+              </a:spcBef>
+              <a:spcAft>
+                <a:spcPts val="0"/>
+              </a:spcAft>
+            </a:pPr>
+            <a:r>
+              <a:rPr sz="780" b="0" i="0">
+                <a:solidFill>
+                  <a:srgbClr val="F5FAFB"/>
+                </a:solidFill>
+                <a:latin typeface="Aptos"/>
+              </a:rPr>
+              <a:t>Immediate / next pour</a:t>
+            </a:r>
+          </a:p>
+        </p:txBody>
+      </p:sp>
+      <p:sp>
+        <p:nvSpPr>
+          <p:cNvPr id="65" name="Rounded Rectangle 64"/>
           <p:cNvSpPr/>
           <p:nvPr/>
         </p:nvSpPr>
@@ -7172,7 +9022,7 @@
       </p:sp>
       <p:sp>
         <p:nvSpPr>
-          <p:cNvPr id="60" name="TextBox 59"/>
+          <p:cNvPr id="66" name="TextBox 65"/>
           <p:cNvSpPr txBox="1"/>
           <p:nvPr/>
         </p:nvSpPr>
@@ -7215,7 +9065,7 @@
       </p:sp>
       <p:sp>
         <p:nvSpPr>
-          <p:cNvPr id="61" name="TextBox 60"/>
+          <p:cNvPr id="67" name="TextBox 66"/>
           <p:cNvSpPr txBox="1"/>
           <p:nvPr/>
         </p:nvSpPr>

</xml_diff>